<commit_message>
Rework APK enrollment flow
</commit_message>
<xml_diff>
--- a/docs/deck/Datalake_Face_Auth_Deck.pptx
+++ b/docs/deck/Datalake_Face_Auth_Deck.pptx
@@ -3561,7 +3561,7 @@
         <p:spPr>
           <a:xfrm>
             <a:off x="868680" y="5989320"/>
-            <a:ext cx="6400800" cy="292608"/>
+            <a:ext cx="9875520" cy="292608"/>
           </a:xfrm>
           <a:prstGeom prst="rect">
             <a:avLst/>
@@ -3579,34 +3579,13 @@
             <a:r>
               <a:rPr lang="en-US" sz="1050" dirty="0">
                 <a:solidFill>
-                  <a:srgbClr val="5A6770"/>
+                  <a:srgbClr val="8B97A5"/>
                 </a:solidFill>
                 <a:latin typeface="Consolas" pitchFamily="34" charset="0"/>
                 <a:ea typeface="Consolas" pitchFamily="34" charset="-122"/>
                 <a:cs typeface="Consolas" pitchFamily="34" charset="-120"/>
               </a:rPr>
-              <a:t>Web demo  </a:t>
-            </a:r>
-            <a:pPr indent="0" marL="0">
-              <a:buNone/>
-            </a:pPr>
-            <a:r>
-              <a:rPr lang="en-US" sz="1050" u="sng" dirty="0">
-                <a:solidFill>
-                  <a:srgbClr val="38E0A5"/>
-                </a:solidFill>
-                <a:latin typeface="Consolas" pitchFamily="34" charset="0"/>
-                <a:ea typeface="Consolas" pitchFamily="34" charset="-122"/>
-                <a:cs typeface="Consolas" pitchFamily="34" charset="-120"/>
-                <a:hlinkClick r:id="rId2" invalidUrl="" action="" tgtFrame="" tooltip="" history="1" highlightClick="0" endSnd="0">
-                  <a:extLst>
-                    <a:ext uri="{A12FA001-AC4F-418D-AE19-62706E023703}">
-                      <ahyp:hlinkClr xmlns:ahyp="http://schemas.microsoft.com/office/drawing/2018/hyperlinkcolor" val="tx"/>
-                    </a:ext>
-                  </a:extLst>
-                </a:hlinkClick>
-              </a:rPr>
-              <a:t>nhai-three.vercel.app</a:t>
+              <a:t>Judge flow: open APK -&gt; choose Verify or Enroll -&gt; local face template -&gt; local verification</a:t>
             </a:r>
             <a:endParaRPr lang="en-US" sz="1050" dirty="0"/>
           </a:p>
@@ -7085,7 +7064,7 @@
                 <a:ea typeface="Consolas" pitchFamily="34" charset="-122"/>
                 <a:cs typeface="Consolas" pitchFamily="34" charset="-120"/>
               </a:rPr>
-              <a:t>Browser demo (Vercel)</a:t>
+              <a:t>Judge package</a:t>
             </a:r>
             <a:endParaRPr lang="en-US" sz="1400" dirty="0"/>
           </a:p>
@@ -7128,7 +7107,7 @@
                 <a:ea typeface="Calibri" pitchFamily="34" charset="-122"/>
                 <a:cs typeface="Calibri" pitchFamily="34" charset="-120"/>
               </a:rPr>
-              <a:t>Vite + React + TypeScript</a:t>
+              <a:t>Universal Android APK</a:t>
             </a:r>
             <a:endParaRPr lang="en-US" sz="1350" dirty="0"/>
           </a:p>
@@ -7149,7 +7128,7 @@
                 <a:ea typeface="Calibri" pitchFamily="34" charset="-122"/>
                 <a:cs typeface="Calibri" pitchFamily="34" charset="-120"/>
               </a:rPr>
-              <a:t>@vladmandic/face-api</a:t>
+              <a:t>ABI split APKs</a:t>
             </a:r>
             <a:endParaRPr lang="en-US" sz="1350" dirty="0"/>
           </a:p>
@@ -7170,7 +7149,7 @@
                 <a:ea typeface="Calibri" pitchFamily="34" charset="-122"/>
                 <a:cs typeface="Calibri" pitchFamily="34" charset="-120"/>
               </a:rPr>
-              <a:t>Web Speech API (offline TTS)</a:t>
+              <a:t>Bundled TFLite models</a:t>
             </a:r>
             <a:endParaRPr lang="en-US" sz="1350" dirty="0"/>
           </a:p>
@@ -7191,7 +7170,7 @@
                 <a:ea typeface="Calibri" pitchFamily="34" charset="-122"/>
                 <a:cs typeface="Calibri" pitchFamily="34" charset="-120"/>
               </a:rPr>
-              <a:t>Playwright E2E</a:t>
+              <a:t>Generated app logo asset</a:t>
             </a:r>
             <a:endParaRPr lang="en-US" sz="1350" dirty="0"/>
           </a:p>
@@ -7629,7 +7608,7 @@
                 <a:ea typeface="Consolas" pitchFamily="34" charset="-122"/>
                 <a:cs typeface="Consolas" pitchFamily="34" charset="-120"/>
               </a:rPr>
-              <a:t>Android APK first, web demo optional</a:t>
+              <a:t>Android APK for judge install</a:t>
             </a:r>
             <a:endParaRPr lang="en-US" sz="3200" dirty="0"/>
           </a:p>
@@ -7895,7 +7874,7 @@
                 <a:ea typeface="Consolas" pitchFamily="34" charset="-122"/>
                 <a:cs typeface="Consolas" pitchFamily="34" charset="-120"/>
               </a:rPr>
-              <a:t>BROWSER DEMO</a:t>
+              <a:t>PACKAGE NOTES</a:t>
             </a:r>
             <a:endParaRPr lang="en-US" sz="1200" dirty="0"/>
           </a:p>
@@ -7941,7 +7920,7 @@
                   </a:extLst>
                 </a:hlinkClick>
               </a:rPr>
-              <a:t>nhai-three.vercel.app</a:t>
+              <a:t>docs/deliverables/README.md</a:t>
             </a:r>
             <a:endParaRPr lang="en-US" sz="1500" dirty="0"/>
           </a:p>
@@ -7980,7 +7959,7 @@
                 <a:ea typeface="Calibri" pitchFamily="34" charset="-122"/>
                 <a:cs typeface="Calibri" pitchFamily="34" charset="-120"/>
               </a:rPr>
-              <a:t>Open on a phone or laptop, allow the camera, enroll and verify.</a:t>
+              <a:t>Install command, APK hashes, Android target and iOS packaging notes.</a:t>
             </a:r>
             <a:endParaRPr lang="en-US" sz="1250" dirty="0"/>
           </a:p>
@@ -8013,7 +7992,7 @@
       </p:sp>
       <p:pic>
         <p:nvPicPr>
-          <p:cNvPr id="15" name="Image 1" descr="/Users/parth/nhai/docs/deck/assets/qr-demo.png">    </p:cNvPr>
+          <p:cNvPr id="15" name="Image 1" descr="/Users/parth/nhai/docs/deck/assets/qr-github.png">    </p:cNvPr>
           <p:cNvPicPr>
             <a:picLocks noChangeAspect="1"/>
           </p:cNvPicPr>
@@ -8180,7 +8159,7 @@
                 <a:ea typeface="Calibri" pitchFamily="34" charset="-122"/>
                 <a:cs typeface="Calibri" pitchFamily="34" charset="-120"/>
               </a:rPr>
-              <a:t>Native app, web demo and backend, with full documentation.</a:t>
+              <a:t>Native app, backend and full documentation.</a:t>
             </a:r>
             <a:endParaRPr lang="en-US" sz="1250" dirty="0"/>
           </a:p>
@@ -9590,7 +9569,7 @@
                 <a:ea typeface="Consolas" pitchFamily="34" charset="-122"/>
                 <a:cs typeface="Consolas" pitchFamily="34" charset="-120"/>
               </a:rPr>
-              <a:t>nhai-three.vercel.app   ·   github.com/perrysolid/NHAI</a:t>
+              <a:t>github.com/perrysolid/NHAI</a:t>
             </a:r>
             <a:endParaRPr lang="en-US" sz="1200" dirty="0"/>
           </a:p>

</xml_diff>

<commit_message>
feat(deck+web): add Vercel demo + demo-video links to deck; remove web network chip
- pitch deck now frames the offline Android APK as the deliverable and the
  Vercel browser app as the demonstration surface, with the demo-video drive
  link on the title and 'try it now' slides (correct per-target QR codes)
- remove the network-status chip from the web header (not needed)
- gitignore deck build artifacts (.venv, node_modules, pdf, qa images)
</commit_message>
<xml_diff>
--- a/docs/deck/Datalake_Face_Auth_Deck.pptx
+++ b/docs/deck/Datalake_Face_Auth_Deck.pptx
@@ -3525,7 +3525,7 @@
                 <a:ea typeface="Consolas" pitchFamily="34" charset="-122"/>
                 <a:cs typeface="Consolas" pitchFamily="34" charset="-120"/>
               </a:rPr>
-              <a:t>Android APK  </a:t>
+              <a:t>Offline APK  </a:t>
             </a:r>
             <a:pPr indent="0" marL="0">
               <a:buNone/>
@@ -3560,8 +3560,8 @@
         </p:nvSpPr>
         <p:spPr>
           <a:xfrm>
-            <a:off x="868680" y="5989320"/>
-            <a:ext cx="9875520" cy="292608"/>
+            <a:off x="868680" y="5897880"/>
+            <a:ext cx="10881360" cy="274320"/>
           </a:xfrm>
           <a:prstGeom prst="rect">
             <a:avLst/>
@@ -3577,17 +3577,112 @@
               <a:buNone/>
             </a:pPr>
             <a:r>
-              <a:rPr lang="en-US" sz="1050" dirty="0">
-                <a:solidFill>
-                  <a:srgbClr val="8B97A5"/>
+              <a:rPr lang="en-US" sz="950" dirty="0">
+                <a:solidFill>
+                  <a:srgbClr val="5A6770"/>
                 </a:solidFill>
                 <a:latin typeface="Consolas" pitchFamily="34" charset="0"/>
                 <a:ea typeface="Consolas" pitchFamily="34" charset="-122"/>
                 <a:cs typeface="Consolas" pitchFamily="34" charset="-120"/>
               </a:rPr>
-              <a:t>Judge flow: open APK -&gt; choose Verify or Enroll -&gt; local face template -&gt; local verification</a:t>
-            </a:r>
-            <a:endParaRPr lang="en-US" sz="1050" dirty="0"/>
+              <a:t>Browser demo (Vercel)  </a:t>
+            </a:r>
+            <a:pPr indent="0" marL="0">
+              <a:buNone/>
+            </a:pPr>
+            <a:r>
+              <a:rPr lang="en-US" sz="950" u="sng" dirty="0">
+                <a:solidFill>
+                  <a:srgbClr val="38E0A5"/>
+                </a:solidFill>
+                <a:latin typeface="Consolas" pitchFamily="34" charset="0"/>
+                <a:ea typeface="Consolas" pitchFamily="34" charset="-122"/>
+                <a:cs typeface="Consolas" pitchFamily="34" charset="-120"/>
+                <a:hlinkClick r:id="rId2" invalidUrl="" action="" tgtFrame="" tooltip="" history="1" highlightClick="0" endSnd="0">
+                  <a:extLst>
+                    <a:ext uri="{A12FA001-AC4F-418D-AE19-62706E023703}">
+                      <ahyp:hlinkClr xmlns:ahyp="http://schemas.microsoft.com/office/drawing/2018/hyperlinkcolor" val="tx"/>
+                    </a:ext>
+                  </a:extLst>
+                </a:hlinkClick>
+              </a:rPr>
+              <a:t>nhai-three.vercel.app</a:t>
+            </a:r>
+            <a:pPr indent="0" marL="0">
+              <a:buNone/>
+            </a:pPr>
+            <a:r>
+              <a:rPr lang="en-US" sz="950" dirty="0">
+                <a:solidFill>
+                  <a:srgbClr val="5A6770"/>
+                </a:solidFill>
+                <a:latin typeface="Consolas" pitchFamily="34" charset="0"/>
+                <a:ea typeface="Consolas" pitchFamily="34" charset="-122"/>
+                <a:cs typeface="Consolas" pitchFamily="34" charset="-120"/>
+              </a:rPr>
+              <a:t>   —   offline Android APK is the deliverable; the web app is for demonstration only</a:t>
+            </a:r>
+            <a:endParaRPr lang="en-US" sz="950" dirty="0"/>
+          </a:p>
+        </p:txBody>
+      </p:sp>
+      <p:sp>
+        <p:nvSpPr>
+          <p:cNvPr id="34" name="Text 32"/>
+          <p:cNvSpPr/>
+          <p:nvPr/>
+        </p:nvSpPr>
+        <p:spPr>
+          <a:xfrm>
+            <a:off x="868680" y="6217920"/>
+            <a:ext cx="10881360" cy="274320"/>
+          </a:xfrm>
+          <a:prstGeom prst="rect">
+            <a:avLst/>
+          </a:prstGeom>
+          <a:noFill/>
+          <a:ln/>
+        </p:spPr>
+        <p:txBody>
+          <a:bodyPr wrap="square" lIns="0" tIns="0" rIns="0" bIns="0" rtlCol="0" anchor="ctr"/>
+          <a:lstStyle/>
+          <a:p>
+            <a:pPr indent="0" marL="0">
+              <a:buNone/>
+            </a:pPr>
+            <a:r>
+              <a:rPr lang="en-US" sz="950" dirty="0">
+                <a:solidFill>
+                  <a:srgbClr val="5A6770"/>
+                </a:solidFill>
+                <a:latin typeface="Consolas" pitchFamily="34" charset="0"/>
+                <a:ea typeface="Consolas" pitchFamily="34" charset="-122"/>
+                <a:cs typeface="Consolas" pitchFamily="34" charset="-120"/>
+              </a:rPr>
+              <a:t>Demo video  </a:t>
+            </a:r>
+            <a:pPr indent="0" marL="0">
+              <a:buNone/>
+            </a:pPr>
+            <a:r>
+              <a:rPr lang="en-US" sz="950" u="sng" dirty="0">
+                <a:solidFill>
+                  <a:srgbClr val="38E0A5"/>
+                </a:solidFill>
+                <a:latin typeface="Consolas" pitchFamily="34" charset="0"/>
+                <a:ea typeface="Consolas" pitchFamily="34" charset="-122"/>
+                <a:cs typeface="Consolas" pitchFamily="34" charset="-120"/>
+                <a:hlinkClick r:id="rId3" invalidUrl="" action="" tgtFrame="" tooltip="" history="1" highlightClick="0" endSnd="0">
+                  <a:extLst>
+                    <a:ext uri="{A12FA001-AC4F-418D-AE19-62706E023703}">
+                      <ahyp:hlinkClr xmlns:ahyp="http://schemas.microsoft.com/office/drawing/2018/hyperlinkcolor" val="tx"/>
+                    </a:ext>
+                  </a:extLst>
+                </a:hlinkClick>
+              </a:rPr>
+              <a:t>drive.google.com/drive/folders/14rTxUjJ...</a:t>
+            </a:r>
+            <a:endParaRPr lang="en-US" sz="950" dirty="0"/>
           </a:p>
         </p:txBody>
       </p:sp>
@@ -7608,7 +7703,7 @@
                 <a:ea typeface="Consolas" pitchFamily="34" charset="-122"/>
                 <a:cs typeface="Consolas" pitchFamily="34" charset="-120"/>
               </a:rPr>
-              <a:t>Android APK for judge install</a:t>
+              <a:t>Install the offline APK, or try it in a browser</a:t>
             </a:r>
             <a:endParaRPr lang="en-US" sz="3200" dirty="0"/>
           </a:p>
@@ -7674,7 +7769,7 @@
                 <a:ea typeface="Consolas" pitchFamily="34" charset="-122"/>
                 <a:cs typeface="Consolas" pitchFamily="34" charset="-120"/>
               </a:rPr>
-              <a:t>ANDROID APK</a:t>
+              <a:t>ANDROID APK  ·  DELIVERABLE</a:t>
             </a:r>
             <a:endParaRPr lang="en-US" sz="1200" dirty="0"/>
           </a:p>
@@ -7759,7 +7854,7 @@
                 <a:ea typeface="Calibri" pitchFamily="34" charset="-122"/>
                 <a:cs typeface="Calibri" pitchFamily="34" charset="-120"/>
               </a:rPr>
-              <a:t>Primary judge install. Fully offline native authentication with bundled models.</a:t>
+              <a:t>The spec deliverable: fully offline native authentication with bundled models. Installs on any Android 8+ phone.</a:t>
             </a:r>
             <a:endParaRPr lang="en-US" sz="950" dirty="0"/>
           </a:p>
@@ -7874,7 +7969,7 @@
                 <a:ea typeface="Consolas" pitchFamily="34" charset="-122"/>
                 <a:cs typeface="Consolas" pitchFamily="34" charset="-120"/>
               </a:rPr>
-              <a:t>PACKAGE NOTES</a:t>
+              <a:t>BROWSER DEMO  ·  VERCEL</a:t>
             </a:r>
             <a:endParaRPr lang="en-US" sz="1200" dirty="0"/>
           </a:p>
@@ -7920,7 +8015,7 @@
                   </a:extLst>
                 </a:hlinkClick>
               </a:rPr>
-              <a:t>docs/deliverables/README.md</a:t>
+              <a:t>nhai-three.vercel.app</a:t>
             </a:r>
             <a:endParaRPr lang="en-US" sz="1500" dirty="0"/>
           </a:p>
@@ -7959,7 +8054,7 @@
                 <a:ea typeface="Calibri" pitchFamily="34" charset="-122"/>
                 <a:cs typeface="Calibri" pitchFamily="34" charset="-120"/>
               </a:rPr>
-              <a:t>Install command, APK hashes, Android target and iOS packaging notes.</a:t>
+              <a:t>For demonstration only: the same enroll / liveness / verify pipeline in the browser, so judges can try it instantly with no install.</a:t>
             </a:r>
             <a:endParaRPr lang="en-US" sz="1250" dirty="0"/>
           </a:p>
@@ -7992,7 +8087,7 @@
       </p:sp>
       <p:pic>
         <p:nvPicPr>
-          <p:cNvPr id="15" name="Image 1" descr="/Users/parth/nhai/docs/deck/assets/qr-github.png">    </p:cNvPr>
+          <p:cNvPr id="15" name="Image 1" descr="/Users/parth/nhai/docs/deck/assets/qr-demo.png">    </p:cNvPr>
           <p:cNvPicPr>
             <a:picLocks noChangeAspect="1"/>
           </p:cNvPicPr>
@@ -8074,7 +8169,7 @@
                 <a:ea typeface="Consolas" pitchFamily="34" charset="-122"/>
                 <a:cs typeface="Consolas" pitchFamily="34" charset="-120"/>
               </a:rPr>
-              <a:t>SOURCE CODE</a:t>
+              <a:t>OPS DASHBOARD  ·  RENDER</a:t>
             </a:r>
             <a:endParaRPr lang="en-US" sz="1200" dirty="0"/>
           </a:p>
@@ -8120,7 +8215,7 @@
                   </a:extLst>
                 </a:hlinkClick>
               </a:rPr>
-              <a:t>github.com/perrysolid/NHAI</a:t>
+              <a:t>datalake-face-sync.onrender.com/admin</a:t>
             </a:r>
             <a:endParaRPr lang="en-US" sz="1500" dirty="0"/>
           </a:p>
@@ -8159,7 +8254,7 @@
                 <a:ea typeface="Calibri" pitchFamily="34" charset="-122"/>
                 <a:cs typeface="Calibri" pitchFamily="34" charset="-120"/>
               </a:rPr>
-              <a:t>Native app, backend and full documentation.</a:t>
+              <a:t>Synced attendance with authentication-score and drowsiness analytics.</a:t>
             </a:r>
             <a:endParaRPr lang="en-US" sz="1250" dirty="0"/>
           </a:p>
@@ -8192,7 +8287,7 @@
       </p:sp>
       <p:pic>
         <p:nvPicPr>
-          <p:cNvPr id="21" name="Image 2" descr="/Users/parth/nhai/docs/deck/assets/qr-github.png">    </p:cNvPr>
+          <p:cNvPr id="21" name="Image 2" descr="/Users/parth/nhai/docs/deck/assets/qr-dashboard.png">    </p:cNvPr>
           <p:cNvPicPr>
             <a:picLocks noChangeAspect="1"/>
           </p:cNvPicPr>
@@ -8222,8 +8317,8 @@
         </p:nvSpPr>
         <p:spPr>
           <a:xfrm>
-            <a:off x="548640" y="6446520"/>
-            <a:ext cx="3657600" cy="274320"/>
+            <a:off x="822960" y="6035040"/>
+            <a:ext cx="10515600" cy="274320"/>
           </a:xfrm>
           <a:prstGeom prst="rect">
             <a:avLst/>
@@ -8239,52 +8334,112 @@
               <a:buNone/>
             </a:pPr>
             <a:r>
-              <a:rPr lang="en-US" sz="900" spc="200" kern="0" dirty="0">
-                <a:solidFill>
-                  <a:srgbClr val="5A6770"/>
+              <a:rPr lang="en-US" sz="1200" b="1" spc="100" kern="0" dirty="0">
+                <a:solidFill>
+                  <a:srgbClr val="38E0A5"/>
                 </a:solidFill>
                 <a:latin typeface="Consolas" pitchFamily="34" charset="0"/>
                 <a:ea typeface="Consolas" pitchFamily="34" charset="-122"/>
                 <a:cs typeface="Consolas" pitchFamily="34" charset="-120"/>
               </a:rPr>
-              <a:t>DATALAKE FACE AUTH</a:t>
-            </a:r>
-            <a:endParaRPr lang="en-US" sz="900" dirty="0"/>
-          </a:p>
-        </p:txBody>
-      </p:sp>
-      <p:sp>
-        <p:nvSpPr>
-          <p:cNvPr id="23" name="Text 18"/>
-          <p:cNvSpPr/>
-          <p:nvPr/>
-        </p:nvSpPr>
-        <p:spPr>
-          <a:xfrm>
-            <a:off x="7985455" y="6446520"/>
-            <a:ext cx="3108960" cy="274320"/>
-          </a:xfrm>
-          <a:prstGeom prst="rect">
-            <a:avLst/>
-          </a:prstGeom>
-          <a:noFill/>
-          <a:ln/>
-        </p:spPr>
-        <p:txBody>
-          <a:bodyPr wrap="square" lIns="0" tIns="0" rIns="0" bIns="0" rtlCol="0" anchor="ctr"/>
-          <a:lstStyle/>
-          <a:p>
-            <a:pPr algn="r" indent="0" marL="0">
-              <a:buNone/>
-            </a:pPr>
-            <a:r>
-              <a:rPr lang="en-US" sz="900" spc="200" kern="0" dirty="0">
-                <a:solidFill>
-                  <a:srgbClr val="5A6770"/>
+              <a:t>DEMO VIDEO   </a:t>
+            </a:r>
+            <a:pPr indent="0" marL="0">
+              <a:buNone/>
+            </a:pPr>
+            <a:r>
+              <a:rPr lang="en-US" sz="1100" u="sng" dirty="0">
+                <a:solidFill>
+                  <a:srgbClr val="DBE4E8"/>
                 </a:solidFill>
                 <a:latin typeface="Consolas" pitchFamily="34" charset="0"/>
                 <a:ea typeface="Consolas" pitchFamily="34" charset="-122"/>
                 <a:cs typeface="Consolas" pitchFamily="34" charset="-120"/>
+                <a:hlinkClick r:id="rId7" invalidUrl="" action="" tgtFrame="" tooltip="" history="1" highlightClick="0" endSnd="0">
+                  <a:extLst>
+                    <a:ext uri="{A12FA001-AC4F-418D-AE19-62706E023703}">
+                      <ahyp:hlinkClr xmlns:ahyp="http://schemas.microsoft.com/office/drawing/2018/hyperlinkcolor" val="tx"/>
+                    </a:ext>
+                  </a:extLst>
+                </a:hlinkClick>
+              </a:rPr>
+              <a:t>drive.google.com/drive/folders/14rTxUjJ_Wrdt349yWkksgE51m87zO97d</a:t>
+            </a:r>
+            <a:endParaRPr lang="en-US" sz="1200" dirty="0"/>
+          </a:p>
+        </p:txBody>
+      </p:sp>
+      <p:sp>
+        <p:nvSpPr>
+          <p:cNvPr id="23" name="Text 18"/>
+          <p:cNvSpPr/>
+          <p:nvPr/>
+        </p:nvSpPr>
+        <p:spPr>
+          <a:xfrm>
+            <a:off x="548640" y="6446520"/>
+            <a:ext cx="3657600" cy="274320"/>
+          </a:xfrm>
+          <a:prstGeom prst="rect">
+            <a:avLst/>
+          </a:prstGeom>
+          <a:noFill/>
+          <a:ln/>
+        </p:spPr>
+        <p:txBody>
+          <a:bodyPr wrap="square" lIns="0" tIns="0" rIns="0" bIns="0" rtlCol="0" anchor="ctr"/>
+          <a:lstStyle/>
+          <a:p>
+            <a:pPr indent="0" marL="0">
+              <a:buNone/>
+            </a:pPr>
+            <a:r>
+              <a:rPr lang="en-US" sz="900" spc="200" kern="0" dirty="0">
+                <a:solidFill>
+                  <a:srgbClr val="5A6770"/>
+                </a:solidFill>
+                <a:latin typeface="Consolas" pitchFamily="34" charset="0"/>
+                <a:ea typeface="Consolas" pitchFamily="34" charset="-122"/>
+                <a:cs typeface="Consolas" pitchFamily="34" charset="-120"/>
+              </a:rPr>
+              <a:t>DATALAKE FACE AUTH</a:t>
+            </a:r>
+            <a:endParaRPr lang="en-US" sz="900" dirty="0"/>
+          </a:p>
+        </p:txBody>
+      </p:sp>
+      <p:sp>
+        <p:nvSpPr>
+          <p:cNvPr id="24" name="Text 19"/>
+          <p:cNvSpPr/>
+          <p:nvPr/>
+        </p:nvSpPr>
+        <p:spPr>
+          <a:xfrm>
+            <a:off x="7985455" y="6446520"/>
+            <a:ext cx="3108960" cy="274320"/>
+          </a:xfrm>
+          <a:prstGeom prst="rect">
+            <a:avLst/>
+          </a:prstGeom>
+          <a:noFill/>
+          <a:ln/>
+        </p:spPr>
+        <p:txBody>
+          <a:bodyPr wrap="square" lIns="0" tIns="0" rIns="0" bIns="0" rtlCol="0" anchor="ctr"/>
+          <a:lstStyle/>
+          <a:p>
+            <a:pPr algn="r" indent="0" marL="0">
+              <a:buNone/>
+            </a:pPr>
+            <a:r>
+              <a:rPr lang="en-US" sz="900" spc="200" kern="0" dirty="0">
+                <a:solidFill>
+                  <a:srgbClr val="5A6770"/>
+                </a:solidFill>
+                <a:latin typeface="Consolas" pitchFamily="34" charset="0"/>
+                <a:ea typeface="Consolas" pitchFamily="34" charset="-122"/>
+                <a:cs typeface="Consolas" pitchFamily="34" charset="-120"/>
               </a:rPr>
               <a:t>NHAI DATALAKE 3.0</a:t>
             </a:r>
@@ -8294,7 +8449,7 @@
       </p:sp>
       <p:sp>
         <p:nvSpPr>
-          <p:cNvPr id="24" name="Text 19"/>
+          <p:cNvPr id="25" name="Text 20"/>
           <p:cNvSpPr/>
           <p:nvPr/>
         </p:nvSpPr>

</xml_diff>